<commit_message>
Refactor pitch presentation and solutions brief to adopt Solutions Consultant interview perspective
</commit_message>
<xml_diff>
--- a/Avaya_Infinity_MCP_Pitch_Deck.pptx
+++ b/Avaya_Infinity_MCP_Pitch_Deck.pptx
@@ -10,6 +10,9 @@
     <p:sldId id="258" r:id="rId9"/>
     <p:sldId id="259" r:id="rId10"/>
     <p:sldId id="260" r:id="rId11"/>
+    <p:sldId id="261" r:id="rId12"/>
+    <p:sldId id="262" r:id="rId13"/>
+    <p:sldId id="263" r:id="rId14"/>
   </p:sldIdLst>
   <p:sldSz cx="12191695" cy="6858000" type="screen4x3"/>
   <p:notesSz cx="6858000" cy="9144000"/>
@@ -3108,8 +3111,8 @@
         </p:nvSpPr>
         <p:spPr>
           <a:xfrm>
-            <a:off x="914400" y="1828800"/>
-            <a:ext cx="10362895" cy="3657600"/>
+            <a:off x="914400" y="1645920"/>
+            <a:ext cx="10362895" cy="4114800"/>
           </a:xfrm>
           <a:prstGeom prst="rect">
             <a:avLst/>
@@ -3123,7 +3126,7 @@
           <a:lstStyle/>
           <a:p>
             <a:pPr>
-              <a:defRPr b="1" sz="5400">
+              <a:defRPr b="1" sz="4600">
                 <a:solidFill>
                   <a:srgbClr val="DA291C"/>
                 </a:solidFill>
@@ -3131,7 +3134,7 @@
               </a:defRPr>
             </a:pPr>
             <a:r>
-              <a:t>AVAYA INFINITY</a:t>
+              <a:t>AVAYA INFINITY MCP CONSOLE</a:t>
             </a:r>
           </a:p>
           <a:p>
@@ -3139,7 +3142,7 @@
               <a:spcBef>
                 <a:spcPts val="800"/>
               </a:spcBef>
-              <a:defRPr sz="2400">
+              <a:defRPr sz="2200">
                 <a:solidFill>
                   <a:srgbClr val="F3F4F6"/>
                 </a:solidFill>
@@ -3147,15 +3150,15 @@
               </a:defRPr>
             </a:pPr>
             <a:r>
-              <a:t>Zero-Trust AI Connection Orchestration &amp; TCO Optimization</a:t>
+              <a:t>Solutions Consultant Technical Demo &amp; Presentation</a:t>
             </a:r>
           </a:p>
           <a:p>
             <a:pPr>
               <a:spcBef>
-                <a:spcPts val="3500"/>
+                <a:spcPts val="3000"/>
               </a:spcBef>
-              <a:defRPr sz="1400">
+              <a:defRPr sz="1500">
                 <a:solidFill>
                   <a:srgbClr val="9CA3AF"/>
                 </a:solidFill>
@@ -3163,11 +3166,27 @@
               </a:defRPr>
             </a:pPr>
             <a:r>
-              <a:t>Sales Leadership &amp; Solution Architect Pitch Deck</a:t>
+              <a:t>A technical deep-dive into why I built this application, what it shows under the hood,</a:t>
             </a:r>
             <a:br/>
             <a:r>
-              <a:t>Standardizing Enterprise AI Bus (MCP) &amp; Databricks Governance</a:t>
+              <a:t>and how it directly demonstrates the business value of Avaya's actual Infinity roadmap.</a:t>
+            </a:r>
+          </a:p>
+          <a:p>
+            <a:pPr>
+              <a:spcBef>
+                <a:spcPts val="4000"/>
+              </a:spcBef>
+              <a:defRPr b="1" sz="1400">
+                <a:solidFill>
+                  <a:srgbClr val="00F0FF"/>
+                </a:solidFill>
+                <a:latin typeface="Outfit"/>
+              </a:defRPr>
+            </a:pPr>
+            <a:r>
+              <a:t>Presented by: Solutions Consultant Candidate</a:t>
             </a:r>
           </a:p>
         </p:txBody>
@@ -3229,7 +3248,7 @@
               </a:defRPr>
             </a:pPr>
             <a:r>
-              <a:t>The Legacy Challenge: Spaghetti Integrations</a:t>
+              <a:t>Why I Built This Application: SC Perspective</a:t>
             </a:r>
           </a:p>
           <a:p>
@@ -3245,7 +3264,7 @@
               </a:defRPr>
             </a:pPr>
             <a:r>
-              <a:t>Direct Connections Scale Badly (N x M Custom Connector Mess)</a:t>
+              <a:t>Bridging Abstract Architecture with Quantifiable C-Suite Value</a:t>
             </a:r>
           </a:p>
         </p:txBody>
@@ -3259,7 +3278,7 @@
         <p:spPr>
           <a:xfrm>
             <a:off x="685800" y="1645920"/>
-            <a:ext cx="5029200" cy="4389120"/>
+            <a:ext cx="5120640" cy="4389120"/>
           </a:xfrm>
           <a:prstGeom prst="rect">
             <a:avLst/>
@@ -3281,7 +3300,7 @@
               </a:defRPr>
             </a:pPr>
             <a:r>
-              <a:t>Direct Point-to-Point Pipeline Pain</a:t>
+              <a:t>The Engineering &amp; Demo Imperative</a:t>
             </a:r>
           </a:p>
           <a:p>
@@ -3289,9 +3308,6 @@
               <a:spcBef>
                 <a:spcPts val="1000"/>
               </a:spcBef>
-              <a:spcAft>
-                <a:spcPts val="200"/>
-              </a:spcAft>
               <a:defRPr sz="1300">
                 <a:solidFill>
                   <a:srgbClr val="9CA3AF"/>
@@ -3300,7 +3316,7 @@
               </a:defRPr>
             </a:pPr>
             <a:r>
-              <a:t>• Custom Glue Code: Every database requires bespoke API adapters and custom schemas parsed separately for each model type.</a:t>
+              <a:t>• To 'Show, Not Just Tell': Standardized protocol frameworks like Model Context Protocol (MCP) and Lakehouses are abstract concepts. I built this console to make them visual, interactive, and immediately understandable to C-level buyers.</a:t>
             </a:r>
           </a:p>
           <a:p>
@@ -3308,9 +3324,6 @@
               <a:spcBef>
                 <a:spcPts val="1000"/>
               </a:spcBef>
-              <a:spcAft>
-                <a:spcPts val="200"/>
-              </a:spcAft>
               <a:defRPr sz="1300">
                 <a:solidFill>
                   <a:srgbClr val="9CA3AF"/>
@@ -3319,7 +3332,7 @@
               </a:defRPr>
             </a:pPr>
             <a:r>
-              <a:t>• Hardcoded Credentials: Static tokens and credentials scattered across individual servers, raising security vulnerabilities.</a:t>
+              <a:t>• Sales Enablement Focused: Created a client-ready playground that functions offline (perfect for situations with spotty network coverage) or connects directly to live AI APIs for real tool-calling validation.</a:t>
             </a:r>
           </a:p>
           <a:p>
@@ -3327,9 +3340,6 @@
               <a:spcBef>
                 <a:spcPts val="1000"/>
               </a:spcBef>
-              <a:spcAft>
-                <a:spcPts val="200"/>
-              </a:spcAft>
               <a:defRPr sz="1300">
                 <a:solidFill>
                   <a:srgbClr val="9CA3AF"/>
@@ -3338,26 +3348,7 @@
               </a:defRPr>
             </a:pPr>
             <a:r>
-              <a:t>• Audit Nightmare: Security teams must verify role permissions at every endpoint separately, slowing compliance times.</a:t>
-            </a:r>
-          </a:p>
-          <a:p>
-            <a:pPr>
-              <a:spcBef>
-                <a:spcPts val="1000"/>
-              </a:spcBef>
-              <a:spcAft>
-                <a:spcPts val="200"/>
-              </a:spcAft>
-              <a:defRPr sz="1300">
-                <a:solidFill>
-                  <a:srgbClr val="9CA3AF"/>
-                </a:solidFill>
-                <a:latin typeface="Outfit"/>
-              </a:defRPr>
-            </a:pPr>
-            <a:r>
-              <a:t>• Friction-heavy Updates: Changing database schema triggers cascading code rewrites across the entire pipeline.</a:t>
+              <a:t>• Realistic Scenario Sandbox: Includes pre-configured incident presets (wait-time spikes, churn escalations) that sales engineering teams can run in real-time to walk clients through day-in-the-life contact center challenges.</a:t>
             </a:r>
           </a:p>
         </p:txBody>
@@ -3370,8 +3361,8 @@
         </p:nvSpPr>
         <p:spPr>
           <a:xfrm>
-            <a:off x="6400800" y="1645920"/>
-            <a:ext cx="5029200" cy="4389120"/>
+            <a:off x="6217920" y="1645920"/>
+            <a:ext cx="5120640" cy="4389120"/>
           </a:xfrm>
           <a:prstGeom prst="rect">
             <a:avLst/>
@@ -3387,33 +3378,20 @@
             <a:pPr>
               <a:defRPr b="1" sz="1800">
                 <a:solidFill>
-                  <a:srgbClr val="DA291C"/>
-                </a:solidFill>
-                <a:latin typeface="Outfit"/>
-              </a:defRPr>
-            </a:pPr>
-            <a:r>
-              <a:t>Business Outcomes &amp; Cost Drivers</a:t>
+                  <a:srgbClr val="00F0FF"/>
+                </a:solidFill>
+                <a:latin typeface="Outfit"/>
+              </a:defRPr>
+            </a:pPr>
+            <a:r>
+              <a:t>Interview Alignment &amp; Technical Rigor</a:t>
             </a:r>
           </a:p>
           <a:p>
             <a:pPr>
               <a:spcBef>
-                <a:spcPts val="1400"/>
+                <a:spcPts val="1000"/>
               </a:spcBef>
-              <a:defRPr b="1" sz="1400">
-                <a:solidFill>
-                  <a:srgbClr val="F59E0B"/>
-                </a:solidFill>
-                <a:latin typeface="Outfit"/>
-              </a:defRPr>
-            </a:pPr>
-            <a:r>
-              <a:t>TCO Integration Overhead:</a:t>
-            </a:r>
-          </a:p>
-          <a:p>
-            <a:pPr>
               <a:defRPr sz="1300">
                 <a:solidFill>
                   <a:srgbClr val="9CA3AF"/>
@@ -3422,27 +3400,14 @@
               </a:defRPr>
             </a:pPr>
             <a:r>
-              <a:t> ~ $150,000 / year in engineering maintenance.</a:t>
+              <a:t>✔ Demonstrating SC Competencies: Proves my ability to architect a full-stack dashboard, model complex database nodes, implement visual analytics (Chart.js), and code responsive CSS layouts.</a:t>
             </a:r>
           </a:p>
           <a:p>
             <a:pPr>
               <a:spcBef>
-                <a:spcPts val="1400"/>
+                <a:spcPts val="1000"/>
               </a:spcBef>
-              <a:defRPr b="1" sz="1400">
-                <a:solidFill>
-                  <a:srgbClr val="F59E0B"/>
-                </a:solidFill>
-                <a:latin typeface="Outfit"/>
-              </a:defRPr>
-            </a:pPr>
-            <a:r>
-              <a:t>Agility Deployment Speed:</a:t>
-            </a:r>
-          </a:p>
-          <a:p>
-            <a:pPr>
               <a:defRPr sz="1300">
                 <a:solidFill>
                   <a:srgbClr val="9CA3AF"/>
@@ -3451,27 +3416,14 @@
               </a:defRPr>
             </a:pPr>
             <a:r>
-              <a:t> 4 Months per new enterprise data source.</a:t>
+              <a:t>✔ Strategic Solution Strategy: Directly showcases my grasp of Avaya's product portfolio—highlighting the value proposition of AXP cloud telemetry and ACM core media layers.</a:t>
             </a:r>
           </a:p>
           <a:p>
             <a:pPr>
               <a:spcBef>
-                <a:spcPts val="1400"/>
+                <a:spcPts val="1000"/>
               </a:spcBef>
-              <a:defRPr b="1" sz="1400">
-                <a:solidFill>
-                  <a:srgbClr val="F59E0B"/>
-                </a:solidFill>
-                <a:latin typeface="Outfit"/>
-              </a:defRPr>
-            </a:pPr>
-            <a:r>
-              <a:t>Governance Policy Rating:</a:t>
-            </a:r>
-          </a:p>
-          <a:p>
-            <a:pPr>
               <a:defRPr sz="1300">
                 <a:solidFill>
                   <a:srgbClr val="9CA3AF"/>
@@ -3480,7 +3432,7 @@
               </a:defRPr>
             </a:pPr>
             <a:r>
-              <a:t> High Risk. Redaction is ad-hoc, and LLMs read database schemas directly without strict RBAC gatekeeping.</a:t>
+              <a:t>✔ Interactive Value Pitch: Designed specifically to address Carlos and other sales leaders' target needs—focusing on ROI calculators, compliance controls, and SLA penalty mitigations.</a:t>
             </a:r>
           </a:p>
         </p:txBody>
@@ -3542,7 +3494,7 @@
               </a:defRPr>
             </a:pPr>
             <a:r>
-              <a:t>The Solution: Avaya Infinity MCP Bus</a:t>
+              <a:t>What the Application Actually Shows</a:t>
             </a:r>
           </a:p>
           <a:p>
@@ -3558,7 +3510,7 @@
               </a:defRPr>
             </a:pPr>
             <a:r>
-              <a:t>Unified Connection Gateway (N + M Plug-and-Play Standardization)</a:t>
+              <a:t>An Interactive Guided Tour of the Core Modules Built</a:t>
             </a:r>
           </a:p>
         </p:txBody>
@@ -3572,7 +3524,7 @@
         <p:spPr>
           <a:xfrm>
             <a:off x="685800" y="1645920"/>
-            <a:ext cx="5029200" cy="4389120"/>
+            <a:ext cx="5029200" cy="2011680"/>
           </a:xfrm>
           <a:prstGeom prst="rect">
             <a:avLst/>
@@ -3586,23 +3538,23 @@
           <a:lstStyle/>
           <a:p>
             <a:pPr>
-              <a:defRPr b="1" sz="1800">
-                <a:solidFill>
-                  <a:srgbClr val="F3F4F6"/>
-                </a:solidFill>
-                <a:latin typeface="Outfit"/>
-              </a:defRPr>
-            </a:pPr>
-            <a:r>
-              <a:t>Universal Connection Standards</a:t>
+              <a:defRPr b="1" sz="1600">
+                <a:solidFill>
+                  <a:srgbClr val="00F0FF"/>
+                </a:solidFill>
+                <a:latin typeface="Outfit"/>
+              </a:defRPr>
+            </a:pPr>
+            <a:r>
+              <a:t>1. Live Protocol Trace (The 'How')</a:t>
             </a:r>
           </a:p>
           <a:p>
             <a:pPr>
               <a:spcBef>
-                <a:spcPts val="1000"/>
+                <a:spcPts val="400"/>
               </a:spcBef>
-              <a:defRPr sz="1300">
+              <a:defRPr sz="1200">
                 <a:solidFill>
                   <a:srgbClr val="9CA3AF"/>
                 </a:solidFill>
@@ -3610,55 +3562,7 @@
               </a:defRPr>
             </a:pPr>
             <a:r>
-              <a:t>• The 'USB-C for AI': Standardized Model Context Protocol client-server architecture eliminates point-to-point custom wrappers.</a:t>
-            </a:r>
-          </a:p>
-          <a:p>
-            <a:pPr>
-              <a:spcBef>
-                <a:spcPts val="1000"/>
-              </a:spcBef>
-              <a:defRPr sz="1300">
-                <a:solidFill>
-                  <a:srgbClr val="9CA3AF"/>
-                </a:solidFill>
-                <a:latin typeface="Outfit"/>
-              </a:defRPr>
-            </a:pPr>
-            <a:r>
-              <a:t>• Dynamic Discovery: Secure MCP Gateway automatically queries registered silos (Postgres, CRM, SharePoint) to expose resources, tools, and prompt structures on-the-fly.</a:t>
-            </a:r>
-          </a:p>
-          <a:p>
-            <a:pPr>
-              <a:spcBef>
-                <a:spcPts val="1000"/>
-              </a:spcBef>
-              <a:defRPr sz="1300">
-                <a:solidFill>
-                  <a:srgbClr val="9CA3AF"/>
-                </a:solidFill>
-                <a:latin typeface="Outfit"/>
-              </a:defRPr>
-            </a:pPr>
-            <a:r>
-              <a:t>• Separation of Concerns: Data repositories declare query scopes; LLMs consume clean APIs without direct table credentials.</a:t>
-            </a:r>
-          </a:p>
-          <a:p>
-            <a:pPr>
-              <a:spcBef>
-                <a:spcPts val="1000"/>
-              </a:spcBef>
-              <a:defRPr sz="1300">
-                <a:solidFill>
-                  <a:srgbClr val="9CA3AF"/>
-                </a:solidFill>
-                <a:latin typeface="Outfit"/>
-              </a:defRPr>
-            </a:pPr>
-            <a:r>
-              <a:t>• Multi-Brain Swap: Swap underlying AI brains (Gemini, Claude, GPT) instantly without refactoring data layer connectors.</a:t>
+              <a:t>Provides step-by-step transparency. It captures raw JSON inputs, tool schemas, and output payloads exchanged between the model client and MCP database servers, demystifying AI decision logic.</a:t>
             </a:r>
           </a:p>
         </p:txBody>
@@ -3671,8 +3575,8 @@
         </p:nvSpPr>
         <p:spPr>
           <a:xfrm>
-            <a:off x="6400800" y="1645920"/>
-            <a:ext cx="5029200" cy="4389120"/>
+            <a:off x="6217920" y="1645920"/>
+            <a:ext cx="5029200" cy="2011680"/>
           </a:xfrm>
           <a:prstGeom prst="rect">
             <a:avLst/>
@@ -3686,7 +3590,59 @@
           <a:lstStyle/>
           <a:p>
             <a:pPr>
-              <a:defRPr b="1" sz="1800">
+              <a:defRPr b="1" sz="1600">
+                <a:solidFill>
+                  <a:srgbClr val="F59E0B"/>
+                </a:solidFill>
+                <a:latin typeface="Outfit"/>
+              </a:defRPr>
+            </a:pPr>
+            <a:r>
+              <a:t>2. Unified Lakehouse &amp; Silos (The 'What')</a:t>
+            </a:r>
+          </a:p>
+          <a:p>
+            <a:pPr>
+              <a:spcBef>
+                <a:spcPts val="400"/>
+              </a:spcBef>
+              <a:defRPr sz="1200">
+                <a:solidFill>
+                  <a:srgbClr val="9CA3AF"/>
+                </a:solidFill>
+                <a:latin typeface="Outfit"/>
+              </a:defRPr>
+            </a:pPr>
+            <a:r>
+              <a:t>Visualizes simulated CRM profiles, SQL database logs, and SharePoint Knowledge Base tables. Proves that models can retrieve siloed customer data without copying or duplicating data repositories.</a:t>
+            </a:r>
+          </a:p>
+        </p:txBody>
+      </p:sp>
+      <p:sp>
+        <p:nvSpPr>
+          <p:cNvPr id="5" name="TextBox 4"/>
+          <p:cNvSpPr txBox="1"/>
+          <p:nvPr/>
+        </p:nvSpPr>
+        <p:spPr>
+          <a:xfrm>
+            <a:off x="685800" y="3931920"/>
+            <a:ext cx="5029200" cy="2011680"/>
+          </a:xfrm>
+          <a:prstGeom prst="rect">
+            <a:avLst/>
+          </a:prstGeom>
+          <a:noFill/>
+        </p:spPr>
+        <p:txBody>
+          <a:bodyPr wrap="square">
+            <a:spAutoFit/>
+          </a:bodyPr>
+          <a:lstStyle/>
+          <a:p>
+            <a:pPr>
+              <a:defRPr b="1" sz="1600">
                 <a:solidFill>
                   <a:srgbClr val="10B981"/>
                 </a:solidFill>
@@ -3694,28 +3650,15 @@
               </a:defRPr>
             </a:pPr>
             <a:r>
-              <a:t>Unified Sales Outcome Benefits</a:t>
+              <a:t>3. Interactive Network Playground (The 'Why')</a:t>
             </a:r>
           </a:p>
           <a:p>
             <a:pPr>
               <a:spcBef>
-                <a:spcPts val="1400"/>
+                <a:spcPts val="400"/>
               </a:spcBef>
-              <a:defRPr b="1" sz="1400">
-                <a:solidFill>
-                  <a:srgbClr val="10B981"/>
-                </a:solidFill>
-                <a:latin typeface="Outfit"/>
-              </a:defRPr>
-            </a:pPr>
-            <a:r>
-              <a:t>TCO Integration Cost:</a:t>
-            </a:r>
-          </a:p>
-          <a:p>
-            <a:pPr>
-              <a:defRPr sz="1300">
+              <a:defRPr sz="1200">
                 <a:solidFill>
                   <a:srgbClr val="9CA3AF"/>
                 </a:solidFill>
@@ -3723,28 +3666,51 @@
               </a:defRPr>
             </a:pPr>
             <a:r>
-              <a:t> $15,000 / year (90% savings over custom code).</a:t>
+              <a:t>Animates active connection lines and flowing data packets. Instantly models legacy integration mess (N x M spaghetti) vs the clean unified bus (N + M MCP) and Edify policy routing layouts.</a:t>
+            </a:r>
+          </a:p>
+        </p:txBody>
+      </p:sp>
+      <p:sp>
+        <p:nvSpPr>
+          <p:cNvPr id="6" name="TextBox 5"/>
+          <p:cNvSpPr txBox="1"/>
+          <p:nvPr/>
+        </p:nvSpPr>
+        <p:spPr>
+          <a:xfrm>
+            <a:off x="6217920" y="3931920"/>
+            <a:ext cx="5029200" cy="2011680"/>
+          </a:xfrm>
+          <a:prstGeom prst="rect">
+            <a:avLst/>
+          </a:prstGeom>
+          <a:noFill/>
+        </p:spPr>
+        <p:txBody>
+          <a:bodyPr wrap="square">
+            <a:spAutoFit/>
+          </a:bodyPr>
+          <a:lstStyle/>
+          <a:p>
+            <a:pPr>
+              <a:defRPr b="1" sz="1600">
+                <a:solidFill>
+                  <a:srgbClr val="DA291C"/>
+                </a:solidFill>
+                <a:latin typeface="Outfit"/>
+              </a:defRPr>
+            </a:pPr>
+            <a:r>
+              <a:t>4. Databricks Governance Log (The 'Security')</a:t>
             </a:r>
           </a:p>
           <a:p>
             <a:pPr>
               <a:spcBef>
-                <a:spcPts val="1400"/>
+                <a:spcPts val="400"/>
               </a:spcBef>
-              <a:defRPr b="1" sz="1400">
-                <a:solidFill>
-                  <a:srgbClr val="10B981"/>
-                </a:solidFill>
-                <a:latin typeface="Outfit"/>
-              </a:defRPr>
-            </a:pPr>
-            <a:r>
-              <a:t>Agility Deployment Speed:</a:t>
-            </a:r>
-          </a:p>
-          <a:p>
-            <a:pPr>
-              <a:defRPr sz="1300">
+              <a:defRPr sz="1200">
                 <a:solidFill>
                   <a:srgbClr val="9CA3AF"/>
                 </a:solidFill>
@@ -3752,36 +3718,7 @@
               </a:defRPr>
             </a:pPr>
             <a:r>
-              <a:t> 2 Hours. Fast plug-and-play capability to connect database nodes.</a:t>
-            </a:r>
-          </a:p>
-          <a:p>
-            <a:pPr>
-              <a:spcBef>
-                <a:spcPts val="1400"/>
-              </a:spcBef>
-              <a:defRPr b="1" sz="1400">
-                <a:solidFill>
-                  <a:srgbClr val="10B981"/>
-                </a:solidFill>
-                <a:latin typeface="Outfit"/>
-              </a:defRPr>
-            </a:pPr>
-            <a:r>
-              <a:t>Governance Policy Rating:</a:t>
-            </a:r>
-          </a:p>
-          <a:p>
-            <a:pPr>
-              <a:defRPr sz="1300">
-                <a:solidFill>
-                  <a:srgbClr val="9CA3AF"/>
-                </a:solidFill>
-                <a:latin typeface="Outfit"/>
-              </a:defRPr>
-            </a:pPr>
-            <a:r>
-              <a:t> Secure &amp; Compliant. Low threat footprint; centralized RBAC policies protect underlying data layers.</a:t>
+              <a:t>Logs compliance activities in real-time. Highlights PII redactions, RBAC access blocks, and logs all gateway actions directly into Unity Catalog audit tables for total transparency.</a:t>
             </a:r>
           </a:p>
         </p:txBody>
@@ -3843,7 +3780,7 @@
               </a:defRPr>
             </a:pPr>
             <a:r>
-              <a:t>Zero-Trust Governance: Databricks Unity Catalog</a:t>
+              <a:t>How It Represents Avaya's Actual Infinity</a:t>
             </a:r>
           </a:p>
           <a:p>
@@ -3859,7 +3796,7 @@
               </a:defRPr>
             </a:pPr>
             <a:r>
-              <a:t>Centralized Access Guardrails, Privacy Controls, and Audits</a:t>
+              <a:t>Translating Architecture Guidelines to Interactive Solutions</a:t>
             </a:r>
           </a:p>
         </p:txBody>
@@ -3873,7 +3810,7 @@
         <p:spPr>
           <a:xfrm>
             <a:off x="685800" y="1645920"/>
-            <a:ext cx="5029200" cy="4389120"/>
+            <a:ext cx="5120640" cy="4389120"/>
           </a:xfrm>
           <a:prstGeom prst="rect">
             <a:avLst/>
@@ -3895,7 +3832,7 @@
               </a:defRPr>
             </a:pPr>
             <a:r>
-              <a:t>Centralized Compliance Enforcements</a:t>
+              <a:t>Core Infrastructure Pillars</a:t>
             </a:r>
           </a:p>
           <a:p>
@@ -3911,7 +3848,7 @@
               </a:defRPr>
             </a:pPr>
             <a:r>
-              <a:t>• PII HIPAA Redaction: Central parser intercepts prompts and results to mask patient/customer names (e.g. Jeff Edwards -&gt; J*** E******).</a:t>
+              <a:t>• AI-Agnostic BYOAI Framework: In the UI, the operator can switch AI models seamlessly. This models Avaya's commitment to avoiding model lock-in, letting customers bring any LLM client to their data.</a:t>
             </a:r>
           </a:p>
           <a:p>
@@ -3927,7 +3864,7 @@
               </a:defRPr>
             </a:pPr>
             <a:r>
-              <a:t>• Restricted DB Access (RBAC): Automatically blocks raw tool calls to protected tables with a 403 authorization error.</a:t>
+              <a:t>• Zero-Copy Data Access: Under the hood, the console queries database tables dynamically via schema tool definitions. Data remains in-place, aligned with Avaya's zero-copy architecture roadmap.</a:t>
             </a:r>
           </a:p>
           <a:p>
@@ -3943,23 +3880,7 @@
               </a:defRPr>
             </a:pPr>
             <a:r>
-              <a:t>• Live Audit Trail: Every LLM query, database invocation, and security exception is logged instantly to Databricks Audit tables.</a:t>
-            </a:r>
-          </a:p>
-          <a:p>
-            <a:pPr>
-              <a:spcBef>
-                <a:spcPts val="1000"/>
-              </a:spcBef>
-              <a:defRPr sz="1300">
-                <a:solidFill>
-                  <a:srgbClr val="9CA3AF"/>
-                </a:solidFill>
-                <a:latin typeface="Outfit"/>
-              </a:defRPr>
-            </a:pPr>
-            <a:r>
-              <a:t>• Zero-Copy Architecture: Models query databases in-place; no separate copies of client contact history stored on external disks.</a:t>
+              <a:t>• Edify Journey Flowchart: An animated flowchart diagram mapping dynamic CX stream packet routes, illustrating how Avaya Infinity handles no-code policy orchestration.</a:t>
             </a:r>
           </a:p>
         </p:txBody>
@@ -3972,8 +3893,8 @@
         </p:nvSpPr>
         <p:spPr>
           <a:xfrm>
-            <a:off x="6400800" y="1645920"/>
-            <a:ext cx="5029200" cy="4389120"/>
+            <a:off x="6217920" y="1645920"/>
+            <a:ext cx="5120640" cy="4389120"/>
           </a:xfrm>
           <a:prstGeom prst="rect">
             <a:avLst/>
@@ -3995,71 +3916,55 @@
               </a:defRPr>
             </a:pPr>
             <a:r>
-              <a:t>Compliance Metrics Dashboard</a:t>
+              <a:t>Operational Controls &amp; Telemetry</a:t>
             </a:r>
           </a:p>
           <a:p>
             <a:pPr>
               <a:spcBef>
-                <a:spcPts val="1200"/>
+                <a:spcPts val="1000"/>
               </a:spcBef>
               <a:defRPr sz="1300">
                 <a:solidFill>
-                  <a:srgbClr val="F3F4F6"/>
-                </a:solidFill>
-                <a:latin typeface="Outfit"/>
-              </a:defRPr>
-            </a:pPr>
-            <a:r>
-              <a:t>✔ PII Masked Count: Baseline 24 names auto-redacted in active simulation runs.</a:t>
+                  <a:srgbClr val="9CA3AF"/>
+                </a:solidFill>
+                <a:latin typeface="Outfit"/>
+              </a:defRPr>
+            </a:pPr>
+            <a:r>
+              <a:t>✔ Tandem Care Checkpoint: Triggers a visual checkpoint requiring supervisor authorization for high-stakes actions, reflecting Avaya's human-in-the-loop safety roadmap.</a:t>
             </a:r>
           </a:p>
           <a:p>
             <a:pPr>
               <a:spcBef>
-                <a:spcPts val="1200"/>
+                <a:spcPts val="1000"/>
               </a:spcBef>
               <a:defRPr sz="1300">
                 <a:solidFill>
-                  <a:srgbClr val="F3F4F6"/>
-                </a:solidFill>
-                <a:latin typeface="Outfit"/>
-              </a:defRPr>
-            </a:pPr>
-            <a:r>
-              <a:t>✔ Blocks Enforced: Real-time prevention of access violations (preventing data leaks in tool execution).</a:t>
+                  <a:srgbClr val="9CA3AF"/>
+                </a:solidFill>
+                <a:latin typeface="Outfit"/>
+              </a:defRPr>
+            </a:pPr>
+            <a:r>
+              <a:t>✔ Multi-Layer Telemetry Coexistence: Visualizes cloud events (AXP) and voice trunk parameters (ACM Jitter/Loss/MOS) side-by-side. Demonstrates Avaya's capability to bridge legacy telephony cores with cloud operations.</a:t>
             </a:r>
           </a:p>
           <a:p>
             <a:pPr>
               <a:spcBef>
-                <a:spcPts val="1200"/>
+                <a:spcPts val="1000"/>
               </a:spcBef>
               <a:defRPr sz="1300">
                 <a:solidFill>
-                  <a:srgbClr val="F3F4F6"/>
-                </a:solidFill>
-                <a:latin typeface="Outfit"/>
-              </a:defRPr>
-            </a:pPr>
-            <a:r>
-              <a:t>✔ SLA Health Status: 100% compliance SLA verified by Databricks logging dashboard.</a:t>
-            </a:r>
-          </a:p>
-          <a:p>
-            <a:pPr>
-              <a:spcBef>
-                <a:spcPts val="1200"/>
-              </a:spcBef>
-              <a:defRPr sz="1300">
-                <a:solidFill>
-                  <a:srgbClr val="F3F4F6"/>
-                </a:solidFill>
-                <a:latin typeface="Outfit"/>
-              </a:defRPr>
-            </a:pPr>
-            <a:r>
-              <a:t>✔ Audit Coverage: 100% of data pipeline logs monitored and archived for HIPAA/GDPR reviews.</a:t>
+                  <a:srgbClr val="9CA3AF"/>
+                </a:solidFill>
+                <a:latin typeface="Outfit"/>
+              </a:defRPr>
+            </a:pPr>
+            <a:r>
+              <a:t>✔ Databricks Unity Catalog Alignment: Incorporates PII HIPAA masking and RBAC query block triggers, proving enterprise-grade compliance safeguards.</a:t>
             </a:r>
           </a:p>
         </p:txBody>
@@ -4121,7 +4026,7 @@
               </a:defRPr>
             </a:pPr>
             <a:r>
-              <a:t>Real-World Scenarios &amp; Business ROI Outcomes</a:t>
+              <a:t>Detailed Walkthrough: Unified Lakehouse</a:t>
             </a:r>
           </a:p>
           <a:p>
@@ -4137,7 +4042,7 @@
               </a:defRPr>
             </a:pPr>
             <a:r>
-              <a:t>Quantifying Financial Value in Contact Center Operations</a:t>
+              <a:t>Silo Consolidation &amp; Interactive Data Management Features</a:t>
             </a:r>
           </a:p>
         </p:txBody>
@@ -4151,7 +4056,7 @@
         <p:spPr>
           <a:xfrm>
             <a:off x="685800" y="1645920"/>
-            <a:ext cx="3291840" cy="4389120"/>
+            <a:ext cx="5120640" cy="4389120"/>
           </a:xfrm>
           <a:prstGeom prst="rect">
             <a:avLst/>
@@ -4165,23 +4070,23 @@
           <a:lstStyle/>
           <a:p>
             <a:pPr>
-              <a:defRPr b="1" sz="1600">
-                <a:solidFill>
-                  <a:srgbClr val="00F0FF"/>
-                </a:solidFill>
-                <a:latin typeface="Outfit"/>
-              </a:defRPr>
-            </a:pPr>
-            <a:r>
-              <a:t>1. Queue Recovery Spike</a:t>
+              <a:defRPr b="1" sz="1800">
+                <a:solidFill>
+                  <a:srgbClr val="F3F4F6"/>
+                </a:solidFill>
+                <a:latin typeface="Outfit"/>
+              </a:defRPr>
+            </a:pPr>
+            <a:r>
+              <a:t>Why Silos Are in the Console</a:t>
             </a:r>
           </a:p>
           <a:p>
             <a:pPr>
               <a:spcBef>
-                <a:spcPts val="600"/>
+                <a:spcPts val="1000"/>
               </a:spcBef>
-              <a:defRPr sz="1150">
+              <a:defRPr sz="1300">
                 <a:solidFill>
                   <a:srgbClr val="9CA3AF"/>
                 </a:solidFill>
@@ -4189,15 +4094,15 @@
               </a:defRPr>
             </a:pPr>
             <a:r>
-              <a:t>Scenario: Mandatory team training triggers sudden queue wait time spikes.</a:t>
+              <a:t>• Simulating Real-World Friction: Enterprises have customer history, ticket CRM data, and policies separated across different database platforms. This view shows them all in one place.</a:t>
             </a:r>
           </a:p>
           <a:p>
             <a:pPr>
               <a:spcBef>
-                <a:spcPts val="600"/>
+                <a:spcPts val="1000"/>
               </a:spcBef>
-              <a:defRPr sz="1150">
+              <a:defRPr sz="1300">
                 <a:solidFill>
                   <a:srgbClr val="9CA3AF"/>
                 </a:solidFill>
@@ -4205,31 +4110,15 @@
               </a:defRPr>
             </a:pPr>
             <a:r>
-              <a:t>AI Resolution: Aura AI scans agent timetables, blocks concurrent breaks, and diverts incoming chats to self-service lanes.</a:t>
+              <a:t>• Zero-Copy Verification: Rather than migrating databases to the LLM, the model issues on-the-fly read queries to separate tables, illustrating zero-copy architectural advantages.</a:t>
             </a:r>
           </a:p>
           <a:p>
             <a:pPr>
               <a:spcBef>
-                <a:spcPts val="600"/>
+                <a:spcPts val="1000"/>
               </a:spcBef>
-              <a:defRPr b="1" sz="1150">
-                <a:solidFill>
-                  <a:srgbClr val="10B981"/>
-                </a:solidFill>
-                <a:latin typeface="Outfit"/>
-              </a:defRPr>
-            </a:pPr>
-            <a:r>
-              <a:t>Business Outcome:</a:t>
-            </a:r>
-          </a:p>
-          <a:p>
-            <a:pPr>
-              <a:spcBef>
-                <a:spcPts val="600"/>
-              </a:spcBef>
-              <a:defRPr sz="1150">
+              <a:defRPr sz="1300">
                 <a:solidFill>
                   <a:srgbClr val="9CA3AF"/>
                 </a:solidFill>
@@ -4237,7 +4126,7 @@
               </a:defRPr>
             </a:pPr>
             <a:r>
-              <a:t>Restored wait time from 185s to 15s. Prevented $3,200/day in SLA compliance fines.</a:t>
+              <a:t>• Interactive SharePoint Document Viewer: Users can select actual warranty, tax, or outage documents from a visual index table and immediately read the text clauses used by the AI model.</a:t>
             </a:r>
           </a:p>
         </p:txBody>
@@ -4250,8 +4139,8 @@
         </p:nvSpPr>
         <p:spPr>
           <a:xfrm>
-            <a:off x="4389120" y="1645920"/>
-            <a:ext cx="3291840" cy="4389120"/>
+            <a:off x="6217920" y="1645920"/>
+            <a:ext cx="5120640" cy="4389120"/>
           </a:xfrm>
           <a:prstGeom prst="rect">
             <a:avLst/>
@@ -4265,7 +4154,7 @@
           <a:lstStyle/>
           <a:p>
             <a:pPr>
-              <a:defRPr b="1" sz="1600">
+              <a:defRPr b="1" sz="1800">
                 <a:solidFill>
                   <a:srgbClr val="00F0FF"/>
                 </a:solidFill>
@@ -4273,15 +4162,15 @@
               </a:defRPr>
             </a:pPr>
             <a:r>
-              <a:t>2. VIP Priority Routing</a:t>
+              <a:t>Dynamic Data Silos Features</a:t>
             </a:r>
           </a:p>
           <a:p>
             <a:pPr>
               <a:spcBef>
-                <a:spcPts val="600"/>
+                <a:spcPts val="1000"/>
               </a:spcBef>
-              <a:defRPr sz="1150">
+              <a:defRPr sz="1300">
                 <a:solidFill>
                   <a:srgbClr val="9CA3AF"/>
                 </a:solidFill>
@@ -4289,15 +4178,15 @@
               </a:defRPr>
             </a:pPr>
             <a:r>
-              <a:t>Scenario: SIP trunk voice jitter spikes for active enterprise accounts.</a:t>
+              <a:t>✔ Unified Tables Index: Includes PostgreSQL Call Database, Salesforce/Zendesk CRM Records, and SharePoint Document Libraries.</a:t>
             </a:r>
           </a:p>
           <a:p>
             <a:pPr>
               <a:spcBef>
-                <a:spcPts val="600"/>
+                <a:spcPts val="1000"/>
               </a:spcBef>
-              <a:defRPr sz="1150">
+              <a:defRPr sz="1300">
                 <a:solidFill>
                   <a:srgbClr val="9CA3AF"/>
                 </a:solidFill>
@@ -4305,31 +4194,15 @@
               </a:defRPr>
             </a:pPr>
             <a:r>
-              <a:t>AI Resolution: Tandem Care triggers L3 priority escalation checkpoint requiring supervisor approval.</a:t>
+              <a:t>✔ Interactive Past Interactions Logger: Let's the presenter manually write and submit a supervisor log entry back to the customer's CRM history, showcasing active writebacks.</a:t>
             </a:r>
           </a:p>
           <a:p>
             <a:pPr>
               <a:spcBef>
-                <a:spcPts val="600"/>
+                <a:spcPts val="1000"/>
               </a:spcBef>
-              <a:defRPr b="1" sz="1150">
-                <a:solidFill>
-                  <a:srgbClr val="10B981"/>
-                </a:solidFill>
-                <a:latin typeface="Outfit"/>
-              </a:defRPr>
-            </a:pPr>
-            <a:r>
-              <a:t>Business Outcome:</a:t>
-            </a:r>
-          </a:p>
-          <a:p>
-            <a:pPr>
-              <a:spcBef>
-                <a:spcPts val="600"/>
-              </a:spcBef>
-              <a:defRPr sz="1150">
+              <a:defRPr sz="1300">
                 <a:solidFill>
                   <a:srgbClr val="9CA3AF"/>
                 </a:solidFill>
@@ -4337,21 +4210,47 @@
               </a:defRPr>
             </a:pPr>
             <a:r>
-              <a:t>Rerouted VIP calls in 10s. Retained $24,000 in VIP account contract ARR and secured 100% CSAT.</a:t>
-            </a:r>
-          </a:p>
-        </p:txBody>
-      </p:sp>
-      <p:sp>
-        <p:nvSpPr>
-          <p:cNvPr id="5" name="TextBox 4"/>
+              <a:t>✔ Dynamic Customer Seeding: Adding a new CRM customer profile automatically seeds historical interaction records based on account tiers (VIP vs Basic).</a:t>
+            </a:r>
+          </a:p>
+        </p:txBody>
+      </p:sp>
+    </p:spTree>
+  </p:cSld>
+  <p:clrMapOvr>
+    <a:masterClrMapping/>
+  </p:clrMapOvr>
+</p:sld>
+</file>
+
+<file path=ppt/slides/slide6.xml><?xml version="1.0" encoding="utf-8"?>
+<p:sld xmlns:a="http://schemas.openxmlformats.org/drawingml/2006/main" xmlns:p="http://schemas.openxmlformats.org/presentationml/2006/main" xmlns:r="http://schemas.openxmlformats.org/officeDocument/2006/relationships">
+  <p:cSld>
+    <p:bg>
+      <p:bgPr>
+        <a:solidFill>
+          <a:srgbClr val="0A0E17"/>
+        </a:solidFill>
+        <a:effectLst/>
+      </p:bgPr>
+    </p:bg>
+    <p:spTree>
+      <p:nvGrpSpPr>
+        <p:cNvPr id="1" name=""/>
+        <p:cNvGrpSpPr/>
+        <p:nvPr/>
+      </p:nvGrpSpPr>
+      <p:grpSpPr/>
+      <p:sp>
+        <p:nvSpPr>
+          <p:cNvPr id="2" name="TextBox 1"/>
           <p:cNvSpPr txBox="1"/>
           <p:nvPr/>
         </p:nvSpPr>
         <p:spPr>
           <a:xfrm>
-            <a:off x="8092440" y="1645920"/>
-            <a:ext cx="3291840" cy="4389120"/>
+            <a:off x="685800" y="365760"/>
+            <a:ext cx="10789920" cy="1097280"/>
           </a:xfrm>
           <a:prstGeom prst="rect">
             <a:avLst/>
@@ -4365,7 +4264,23 @@
           <a:lstStyle/>
           <a:p>
             <a:pPr>
-              <a:defRPr b="1" sz="1600">
+              <a:defRPr b="1" sz="2800">
+                <a:solidFill>
+                  <a:srgbClr val="F3F4F6"/>
+                </a:solidFill>
+                <a:latin typeface="Outfit"/>
+              </a:defRPr>
+            </a:pPr>
+            <a:r>
+              <a:t>Detailed Walkthrough: Security &amp; Governance</a:t>
+            </a:r>
+          </a:p>
+          <a:p>
+            <a:pPr>
+              <a:spcBef>
+                <a:spcPts val="400"/>
+              </a:spcBef>
+              <a:defRPr sz="1400">
                 <a:solidFill>
                   <a:srgbClr val="00F0FF"/>
                 </a:solidFill>
@@ -4373,15 +4288,51 @@
               </a:defRPr>
             </a:pPr>
             <a:r>
-              <a:t>3. Churn Prevention ROI</a:t>
+              <a:t>Centralized Policy Enforcement, HIPAA Protections, and Real-Time Auditing</a:t>
+            </a:r>
+          </a:p>
+        </p:txBody>
+      </p:sp>
+      <p:sp>
+        <p:nvSpPr>
+          <p:cNvPr id="3" name="TextBox 2"/>
+          <p:cNvSpPr txBox="1"/>
+          <p:nvPr/>
+        </p:nvSpPr>
+        <p:spPr>
+          <a:xfrm>
+            <a:off x="685800" y="1645920"/>
+            <a:ext cx="5120640" cy="4389120"/>
+          </a:xfrm>
+          <a:prstGeom prst="rect">
+            <a:avLst/>
+          </a:prstGeom>
+          <a:noFill/>
+        </p:spPr>
+        <p:txBody>
+          <a:bodyPr wrap="square">
+            <a:spAutoFit/>
+          </a:bodyPr>
+          <a:lstStyle/>
+          <a:p>
+            <a:pPr>
+              <a:defRPr b="1" sz="1800">
+                <a:solidFill>
+                  <a:srgbClr val="F3F4F6"/>
+                </a:solidFill>
+                <a:latin typeface="Outfit"/>
+              </a:defRPr>
+            </a:pPr>
+            <a:r>
+              <a:t>Governance Controls &amp; Enforcements</a:t>
             </a:r>
           </a:p>
           <a:p>
             <a:pPr>
               <a:spcBef>
-                <a:spcPts val="600"/>
+                <a:spcPts val="1000"/>
               </a:spcBef>
-              <a:defRPr sz="1150">
+              <a:defRPr sz="1300">
                 <a:solidFill>
                   <a:srgbClr val="9CA3AF"/>
                 </a:solidFill>
@@ -4389,15 +4340,15 @@
               </a:defRPr>
             </a:pPr>
             <a:r>
-              <a:t>Scenario: Customer threatens cancellation due to pricing issues.</a:t>
+              <a:t>• Dynamic PII Masking: Automatically redacts sensitive names (e.g. Jeff Edwards -&gt; J*** E******) in raw database tables, JSON parameters, trace payloads, and final chat outputs.</a:t>
             </a:r>
           </a:p>
           <a:p>
             <a:pPr>
               <a:spcBef>
-                <a:spcPts val="600"/>
+                <a:spcPts val="1000"/>
               </a:spcBef>
-              <a:defRPr sz="1150">
+              <a:defRPr sz="1300">
                 <a:solidFill>
                   <a:srgbClr val="9CA3AF"/>
                 </a:solidFill>
@@ -4405,31 +4356,67 @@
               </a:defRPr>
             </a:pPr>
             <a:r>
-              <a:t>AI Resolution: Queries SharePoint KB policies, calculates maximum authorized credit structure, logs coupon trace.</a:t>
+              <a:t>• Centralized Proxy Redaction: Demonstrates that data is protected at the API proxy layer, eliminating the risk of LLM prompts leaking sensitive information.</a:t>
             </a:r>
           </a:p>
           <a:p>
             <a:pPr>
               <a:spcBef>
-                <a:spcPts val="600"/>
+                <a:spcPts val="1000"/>
               </a:spcBef>
-              <a:defRPr b="1" sz="1150">
-                <a:solidFill>
-                  <a:srgbClr val="10B981"/>
-                </a:solidFill>
-                <a:latin typeface="Outfit"/>
-              </a:defRPr>
-            </a:pPr>
-            <a:r>
-              <a:t>Business Outcome:</a:t>
+              <a:defRPr sz="1300">
+                <a:solidFill>
+                  <a:srgbClr val="9CA3AF"/>
+                </a:solidFill>
+                <a:latin typeface="Outfit"/>
+              </a:defRPr>
+            </a:pPr>
+            <a:r>
+              <a:t>• Restricted DB Access Gatekeeping: Toggling the restriction blocks SQL execution instantly, demonstrating Unity Catalog role-based checks yielding 403 Access Denied messages in the trace.</a:t>
+            </a:r>
+          </a:p>
+        </p:txBody>
+      </p:sp>
+      <p:sp>
+        <p:nvSpPr>
+          <p:cNvPr id="4" name="TextBox 3"/>
+          <p:cNvSpPr txBox="1"/>
+          <p:nvPr/>
+        </p:nvSpPr>
+        <p:spPr>
+          <a:xfrm>
+            <a:off x="6217920" y="1645920"/>
+            <a:ext cx="5120640" cy="4389120"/>
+          </a:xfrm>
+          <a:prstGeom prst="rect">
+            <a:avLst/>
+          </a:prstGeom>
+          <a:noFill/>
+        </p:spPr>
+        <p:txBody>
+          <a:bodyPr wrap="square">
+            <a:spAutoFit/>
+          </a:bodyPr>
+          <a:lstStyle/>
+          <a:p>
+            <a:pPr>
+              <a:defRPr b="1" sz="1800">
+                <a:solidFill>
+                  <a:srgbClr val="00F0FF"/>
+                </a:solidFill>
+                <a:latin typeface="Outfit"/>
+              </a:defRPr>
+            </a:pPr>
+            <a:r>
+              <a:t>Governance Audit Dashboard Features</a:t>
             </a:r>
           </a:p>
           <a:p>
             <a:pPr>
               <a:spcBef>
-                <a:spcPts val="600"/>
+                <a:spcPts val="1000"/>
               </a:spcBef>
-              <a:defRPr sz="1150">
+              <a:defRPr sz="1300">
                 <a:solidFill>
                   <a:srgbClr val="9CA3AF"/>
                 </a:solidFill>
@@ -4437,7 +4424,463 @@
               </a:defRPr>
             </a:pPr>
             <a:r>
-              <a:t>Authorized $1,260 retention credit, saving $8,400 contract value. Achieved 6.6x ROI on CAC.</a:t>
+              <a:t>✔ PII Masked Counter: Running tracker tallying every redaction event occurred in active simulation pipelines.</a:t>
+            </a:r>
+          </a:p>
+          <a:p>
+            <a:pPr>
+              <a:spcBef>
+                <a:spcPts val="1000"/>
+              </a:spcBef>
+              <a:defRPr sz="1300">
+                <a:solidFill>
+                  <a:srgbClr val="9CA3AF"/>
+                </a:solidFill>
+                <a:latin typeface="Outfit"/>
+              </a:defRPr>
+            </a:pPr>
+            <a:r>
+              <a:t>✔ Blocked Requests Counter: Real-time count of blocked unauthorized calls, highlighting active security gatekeeping.</a:t>
+            </a:r>
+          </a:p>
+          <a:p>
+            <a:pPr>
+              <a:spcBef>
+                <a:spcPts val="1000"/>
+              </a:spcBef>
+              <a:defRPr sz="1300">
+                <a:solidFill>
+                  <a:srgbClr val="9CA3AF"/>
+                </a:solidFill>
+                <a:latin typeface="Outfit"/>
+              </a:defRPr>
+            </a:pPr>
+            <a:r>
+              <a:t>✔ Compliance SLA Status Indicator: Automatically shows 100% SLA Health, which shifts dynamically if unauthorized query violations exceed safe operating boundaries.</a:t>
+            </a:r>
+          </a:p>
+          <a:p>
+            <a:pPr>
+              <a:spcBef>
+                <a:spcPts val="1000"/>
+              </a:spcBef>
+              <a:defRPr sz="1300">
+                <a:solidFill>
+                  <a:srgbClr val="9CA3AF"/>
+                </a:solidFill>
+                <a:latin typeface="Outfit"/>
+              </a:defRPr>
+            </a:pPr>
+            <a:r>
+              <a:t>✔ Auditable Logs: Standardized log format matching Databricks catalog traces, making compliance checks simple.</a:t>
+            </a:r>
+          </a:p>
+        </p:txBody>
+      </p:sp>
+    </p:spTree>
+  </p:cSld>
+  <p:clrMapOvr>
+    <a:masterClrMapping/>
+  </p:clrMapOvr>
+</p:sld>
+</file>
+
+<file path=ppt/slides/slide7.xml><?xml version="1.0" encoding="utf-8"?>
+<p:sld xmlns:a="http://schemas.openxmlformats.org/drawingml/2006/main" xmlns:p="http://schemas.openxmlformats.org/presentationml/2006/main" xmlns:r="http://schemas.openxmlformats.org/officeDocument/2006/relationships">
+  <p:cSld>
+    <p:bg>
+      <p:bgPr>
+        <a:solidFill>
+          <a:srgbClr val="0A0E17"/>
+        </a:solidFill>
+        <a:effectLst/>
+      </p:bgPr>
+    </p:bg>
+    <p:spTree>
+      <p:nvGrpSpPr>
+        <p:cNvPr id="1" name=""/>
+        <p:cNvGrpSpPr/>
+        <p:nvPr/>
+      </p:nvGrpSpPr>
+      <p:grpSpPr/>
+      <p:sp>
+        <p:nvSpPr>
+          <p:cNvPr id="2" name="TextBox 1"/>
+          <p:cNvSpPr txBox="1"/>
+          <p:nvPr/>
+        </p:nvSpPr>
+        <p:spPr>
+          <a:xfrm>
+            <a:off x="685800" y="365760"/>
+            <a:ext cx="10789920" cy="1097280"/>
+          </a:xfrm>
+          <a:prstGeom prst="rect">
+            <a:avLst/>
+          </a:prstGeom>
+          <a:noFill/>
+        </p:spPr>
+        <p:txBody>
+          <a:bodyPr wrap="square">
+            <a:spAutoFit/>
+          </a:bodyPr>
+          <a:lstStyle/>
+          <a:p>
+            <a:pPr>
+              <a:defRPr b="1" sz="2800">
+                <a:solidFill>
+                  <a:srgbClr val="F3F4F6"/>
+                </a:solidFill>
+                <a:latin typeface="Outfit"/>
+              </a:defRPr>
+            </a:pPr>
+            <a:r>
+              <a:t>Proving the Business Outcome &amp; ROI Case</a:t>
+            </a:r>
+          </a:p>
+          <a:p>
+            <a:pPr>
+              <a:spcBef>
+                <a:spcPts val="400"/>
+              </a:spcBef>
+              <a:defRPr sz="1400">
+                <a:solidFill>
+                  <a:srgbClr val="00F0FF"/>
+                </a:solidFill>
+                <a:latin typeface="Outfit"/>
+              </a:defRPr>
+            </a:pPr>
+            <a:r>
+              <a:t>Translating Telemetry Metrics into Financial Outcomes for Sales Leadership</a:t>
+            </a:r>
+          </a:p>
+        </p:txBody>
+      </p:sp>
+      <p:sp>
+        <p:nvSpPr>
+          <p:cNvPr id="3" name="TextBox 2"/>
+          <p:cNvSpPr txBox="1"/>
+          <p:nvPr/>
+        </p:nvSpPr>
+        <p:spPr>
+          <a:xfrm>
+            <a:off x="685800" y="1645920"/>
+            <a:ext cx="5120640" cy="4389120"/>
+          </a:xfrm>
+          <a:prstGeom prst="rect">
+            <a:avLst/>
+          </a:prstGeom>
+          <a:noFill/>
+        </p:spPr>
+        <p:txBody>
+          <a:bodyPr wrap="square">
+            <a:spAutoFit/>
+          </a:bodyPr>
+          <a:lstStyle/>
+          <a:p>
+            <a:pPr>
+              <a:defRPr b="1" sz="1800">
+                <a:solidFill>
+                  <a:srgbClr val="F3F4F6"/>
+                </a:solidFill>
+                <a:latin typeface="Outfit"/>
+              </a:defRPr>
+            </a:pPr>
+            <a:r>
+              <a:t>The Architecture Playground ROI Calculator</a:t>
+            </a:r>
+          </a:p>
+          <a:p>
+            <a:pPr>
+              <a:spcBef>
+                <a:spcPts val="1000"/>
+              </a:spcBef>
+              <a:defRPr sz="1300">
+                <a:solidFill>
+                  <a:srgbClr val="9CA3AF"/>
+                </a:solidFill>
+                <a:latin typeface="Outfit"/>
+              </a:defRPr>
+            </a:pPr>
+            <a:r>
+              <a:t>• Quantified Cost Reduction: Dynamic calculator card showing Legacy custom connectors ($150,000/yr TCO) vs Avaya Infinity MCP Bus ($15,000/yr TCO)—a 90% maintenance cost savings.</a:t>
+            </a:r>
+          </a:p>
+          <a:p>
+            <a:pPr>
+              <a:spcBef>
+                <a:spcPts val="1000"/>
+              </a:spcBef>
+              <a:defRPr sz="1300">
+                <a:solidFill>
+                  <a:srgbClr val="9CA3AF"/>
+                </a:solidFill>
+                <a:latin typeface="Outfit"/>
+              </a:defRPr>
+            </a:pPr>
+            <a:r>
+              <a:t>• Agility Metric: Compares 4 months deployment cycles for point-to-point custom adapters against 2 hours for standardized MCP client-server registrations.</a:t>
+            </a:r>
+          </a:p>
+          <a:p>
+            <a:pPr>
+              <a:spcBef>
+                <a:spcPts val="1000"/>
+              </a:spcBef>
+              <a:defRPr sz="1300">
+                <a:solidFill>
+                  <a:srgbClr val="9CA3AF"/>
+                </a:solidFill>
+                <a:latin typeface="Outfit"/>
+              </a:defRPr>
+            </a:pPr>
+            <a:r>
+              <a:t>• Security Policy Scope: Measures the compliance exposure difference between Legacy (High Risk endpoint leaks) and Avaya Infinity (Protected unified gateway).</a:t>
+            </a:r>
+          </a:p>
+        </p:txBody>
+      </p:sp>
+      <p:sp>
+        <p:nvSpPr>
+          <p:cNvPr id="4" name="TextBox 3"/>
+          <p:cNvSpPr txBox="1"/>
+          <p:nvPr/>
+        </p:nvSpPr>
+        <p:spPr>
+          <a:xfrm>
+            <a:off x="6217920" y="1645920"/>
+            <a:ext cx="5120640" cy="4389120"/>
+          </a:xfrm>
+          <a:prstGeom prst="rect">
+            <a:avLst/>
+          </a:prstGeom>
+          <a:noFill/>
+        </p:spPr>
+        <p:txBody>
+          <a:bodyPr wrap="square">
+            <a:spAutoFit/>
+          </a:bodyPr>
+          <a:lstStyle/>
+          <a:p>
+            <a:pPr>
+              <a:defRPr b="1" sz="1800">
+                <a:solidFill>
+                  <a:srgbClr val="00F0FF"/>
+                </a:solidFill>
+                <a:latin typeface="Outfit"/>
+              </a:defRPr>
+            </a:pPr>
+            <a:r>
+              <a:t>The Aura AI Business Outcome Banners</a:t>
+            </a:r>
+          </a:p>
+          <a:p>
+            <a:pPr>
+              <a:spcBef>
+                <a:spcPts val="1000"/>
+              </a:spcBef>
+              <a:defRPr sz="1300">
+                <a:solidFill>
+                  <a:srgbClr val="9CA3AF"/>
+                </a:solidFill>
+                <a:latin typeface="Outfit"/>
+              </a:defRPr>
+            </a:pPr>
+            <a:r>
+              <a:t>✔ Queue Performance (Preset 1): Dynamic breakout rescheduling and automated chat diversions prevent $3,200/day in SLA fines.</a:t>
+            </a:r>
+          </a:p>
+          <a:p>
+            <a:pPr>
+              <a:spcBef>
+                <a:spcPts val="1000"/>
+              </a:spcBef>
+              <a:defRPr sz="1300">
+                <a:solidFill>
+                  <a:srgbClr val="9CA3AF"/>
+                </a:solidFill>
+                <a:latin typeface="Outfit"/>
+              </a:defRPr>
+            </a:pPr>
+            <a:r>
+              <a:t>✔ Contract Security (Preset 2): Priority routing VIP callers during jitter spikes retains $24,000 in VIP account contract ARR.</a:t>
+            </a:r>
+          </a:p>
+          <a:p>
+            <a:pPr>
+              <a:spcBef>
+                <a:spcPts val="1000"/>
+              </a:spcBef>
+              <a:defRPr sz="1300">
+                <a:solidFill>
+                  <a:srgbClr val="9CA3AF"/>
+                </a:solidFill>
+                <a:latin typeface="Outfit"/>
+              </a:defRPr>
+            </a:pPr>
+            <a:r>
+              <a:t>✔ Revenue Retention (Preset 5): Leverages policy guidelines to authorize a $1,260 coupon discount to save an $8,400 churn contract, achieving 6.6x ROI on CAC.</a:t>
+            </a:r>
+          </a:p>
+        </p:txBody>
+      </p:sp>
+    </p:spTree>
+  </p:cSld>
+  <p:clrMapOvr>
+    <a:masterClrMapping/>
+  </p:clrMapOvr>
+</p:sld>
+</file>
+
+<file path=ppt/slides/slide8.xml><?xml version="1.0" encoding="utf-8"?>
+<p:sld xmlns:a="http://schemas.openxmlformats.org/drawingml/2006/main" xmlns:p="http://schemas.openxmlformats.org/presentationml/2006/main" xmlns:r="http://schemas.openxmlformats.org/officeDocument/2006/relationships">
+  <p:cSld>
+    <p:bg>
+      <p:bgPr>
+        <a:solidFill>
+          <a:srgbClr val="0A0E17"/>
+        </a:solidFill>
+        <a:effectLst/>
+      </p:bgPr>
+    </p:bg>
+    <p:spTree>
+      <p:nvGrpSpPr>
+        <p:cNvPr id="1" name=""/>
+        <p:cNvGrpSpPr/>
+        <p:nvPr/>
+      </p:nvGrpSpPr>
+      <p:grpSpPr/>
+      <p:sp>
+        <p:nvSpPr>
+          <p:cNvPr id="2" name="TextBox 1"/>
+          <p:cNvSpPr txBox="1"/>
+          <p:nvPr/>
+        </p:nvSpPr>
+        <p:spPr>
+          <a:xfrm>
+            <a:off x="685800" y="365760"/>
+            <a:ext cx="10789920" cy="1097280"/>
+          </a:xfrm>
+          <a:prstGeom prst="rect">
+            <a:avLst/>
+          </a:prstGeom>
+          <a:noFill/>
+        </p:spPr>
+        <p:txBody>
+          <a:bodyPr wrap="square">
+            <a:spAutoFit/>
+          </a:bodyPr>
+          <a:lstStyle/>
+          <a:p>
+            <a:pPr>
+              <a:defRPr b="1" sz="2800">
+                <a:solidFill>
+                  <a:srgbClr val="F3F4F6"/>
+                </a:solidFill>
+                <a:latin typeface="Outfit"/>
+              </a:defRPr>
+            </a:pPr>
+            <a:r>
+              <a:t>Summary: A Complete Sales Pitch Delivery</a:t>
+            </a:r>
+          </a:p>
+          <a:p>
+            <a:pPr>
+              <a:spcBef>
+                <a:spcPts val="400"/>
+              </a:spcBef>
+              <a:defRPr sz="1400">
+                <a:solidFill>
+                  <a:srgbClr val="00F0FF"/>
+                </a:solidFill>
+                <a:latin typeface="Outfit"/>
+              </a:defRPr>
+            </a:pPr>
+            <a:r>
+              <a:t>Aligning Customer Success, Security Compliance, and IT Budgets</a:t>
+            </a:r>
+          </a:p>
+        </p:txBody>
+      </p:sp>
+      <p:sp>
+        <p:nvSpPr>
+          <p:cNvPr id="3" name="TextBox 2"/>
+          <p:cNvSpPr txBox="1"/>
+          <p:nvPr/>
+        </p:nvSpPr>
+        <p:spPr>
+          <a:xfrm>
+            <a:off x="914400" y="1645920"/>
+            <a:ext cx="10362895" cy="4114800"/>
+          </a:xfrm>
+          <a:prstGeom prst="rect">
+            <a:avLst/>
+          </a:prstGeom>
+          <a:noFill/>
+        </p:spPr>
+        <p:txBody>
+          <a:bodyPr wrap="square">
+            <a:spAutoFit/>
+          </a:bodyPr>
+          <a:lstStyle/>
+          <a:p>
+            <a:pPr>
+              <a:defRPr b="1" sz="2000">
+                <a:solidFill>
+                  <a:srgbClr val="00F0FF"/>
+                </a:solidFill>
+                <a:latin typeface="Outfit"/>
+              </a:defRPr>
+            </a:pPr>
+            <a:r>
+              <a:t>Why I Am Prepared to Stand as an Avaya Solutions Consultant:</a:t>
+            </a:r>
+          </a:p>
+          <a:p>
+            <a:pPr>
+              <a:spcBef>
+                <a:spcPts val="1400"/>
+              </a:spcBef>
+              <a:defRPr sz="1450">
+                <a:solidFill>
+                  <a:srgbClr val="F3F4F6"/>
+                </a:solidFill>
+                <a:latin typeface="Outfit"/>
+              </a:defRPr>
+            </a:pPr>
+            <a:r>
+              <a:t>1. Ability to Simplify Complexity: Translated dry protocol specifications (MCP schemas, JSON payloads) into a high-fidelity visual experience that any buyer can easily understand.</a:t>
+            </a:r>
+          </a:p>
+          <a:p>
+            <a:pPr>
+              <a:spcBef>
+                <a:spcPts val="1400"/>
+              </a:spcBef>
+              <a:defRPr sz="1450">
+                <a:solidFill>
+                  <a:srgbClr val="F3F4F6"/>
+                </a:solidFill>
+                <a:latin typeface="Outfit"/>
+              </a:defRPr>
+            </a:pPr>
+            <a:r>
+              <a:t>2. Outcomes-Driven Demos: Put financial results and TCO metrics front and center, ensuring that the technology is directly coupled with the client's business goals ($ savings, SLA compliance, ARR retention).</a:t>
+            </a:r>
+          </a:p>
+          <a:p>
+            <a:pPr>
+              <a:spcBef>
+                <a:spcPts val="1400"/>
+              </a:spcBef>
+              <a:defRPr sz="1450">
+                <a:solidFill>
+                  <a:srgbClr val="F3F4F6"/>
+                </a:solidFill>
+                <a:latin typeface="Outfit"/>
+              </a:defRPr>
+            </a:pPr>
+            <a:r>
+              <a:t>3. Mastery of the Portfolio: Handcrafted an application representing Avaya's core architectural tenets—proving I have the technical depth to consult clients on actual roadmaps.</a:t>
             </a:r>
           </a:p>
         </p:txBody>

</xml_diff>

<commit_message>
Update presenter details in slide deck and brief to Jeff Edwards with matching LinkedIn and GitHub info
</commit_message>
<xml_diff>
--- a/Avaya_Infinity_MCP_Pitch_Deck.pptx
+++ b/Avaya_Infinity_MCP_Pitch_Deck.pptx
@@ -3178,7 +3178,7 @@
               <a:spcBef>
                 <a:spcPts val="4000"/>
               </a:spcBef>
-              <a:defRPr b="1" sz="1400">
+              <a:defRPr b="1" sz="1500">
                 <a:solidFill>
                   <a:srgbClr val="00F0FF"/>
                 </a:solidFill>
@@ -3186,7 +3186,23 @@
               </a:defRPr>
             </a:pPr>
             <a:r>
-              <a:t>Presented by: Solutions Consultant Candidate</a:t>
+              <a:t>Presented by: Jeff Edwards</a:t>
+            </a:r>
+          </a:p>
+          <a:p>
+            <a:pPr>
+              <a:spcBef>
+                <a:spcPts val="1000"/>
+              </a:spcBef>
+              <a:defRPr sz="1100">
+                <a:solidFill>
+                  <a:srgbClr val="9CA3AF"/>
+                </a:solidFill>
+                <a:latin typeface="Outfit"/>
+              </a:defRPr>
+            </a:pPr>
+            <a:r>
+              <a:t>Savannah, GA  |  678-481-5135  |  sbfall96@gmail.com  |  linkedin.com/in/sbfall96  |  github.com/sbfall96-chx/avaya-mcp-demo</a:t>
             </a:r>
           </a:p>
         </p:txBody>

</xml_diff>